<commit_message>
Add contact, JD.com buy link, and AIoT Lab branding to promo materials
Landing page (site/):
- New footer "letterhead": AIoT Lab logo + name linking to aiot.ie.cuhk.edu.hk,
  plus a Contact block (Anlan Peng, pa025@ie.cuhk.edu.hk).
- Hero badge and author credit now link to the AIoT Lab site.
- Hardware section: brand-colored buy buttons with white logo chips —
  Amazon (yellow + smile) and JD.com 京东 (red + JD mark), alongside the
  ThingX direct-buy primary.

README: Nuna pendant buy links (thingx / Amazon / JD.com 京东), AIoT Lab
link, and a Contact line.

PPT (tools/ppt/build_ppt.js): AIoT Lab logo letterhead + Contact line
(email + lab URL); slide rebuilt.

New assets: aiot-lab-logo.{svg,png} (official lab mark), amazon-smile.svg,
jd-logo.png.

Co-Authored-By: Claude Opus 4.8 <noreply@anthropic.com>
</commit_message>
<xml_diff>
--- a/promo/Nuna-Edu-Toolkit-slide.pptx
+++ b/promo/Nuna-Edu-Toolkit-slide.pptx
@@ -877,14 +877,34 @@
       </p:grpSpPr>
       <p:sp>
         <p:nvSpPr>
-          <p:cNvPr id="2" name="Text 0"/>
+          <p:cNvPr id="2" name="Shape 0"/>
           <p:cNvSpPr/>
           <p:nvPr/>
         </p:nvSpPr>
         <p:spPr>
           <a:xfrm>
-            <a:off x="685800" y="640080"/>
-            <a:ext cx="7315200" cy="320040"/>
+            <a:off x="0" y="0"/>
+            <a:ext cx="12191695" cy="1078992"/>
+          </a:xfrm>
+          <a:prstGeom prst="rect">
+            <a:avLst/>
+          </a:prstGeom>
+          <a:solidFill>
+            <a:srgbClr val="740E6C"/>
+          </a:solidFill>
+          <a:ln/>
+        </p:spPr>
+      </p:sp>
+      <p:sp>
+        <p:nvSpPr>
+          <p:cNvPr id="3" name="Text 1"/>
+          <p:cNvSpPr/>
+          <p:nvPr/>
+        </p:nvSpPr>
+        <p:spPr>
+          <a:xfrm>
+            <a:off x="457200" y="0"/>
+            <a:ext cx="7498080" cy="1078992"/>
           </a:xfrm>
           <a:prstGeom prst="rect">
             <a:avLst/>
@@ -900,30 +920,30 @@
               <a:buNone/>
             </a:pPr>
             <a:r>
-              <a:rPr lang="en-US" sz="1300" b="1" spc="200" kern="0" dirty="0">
+              <a:rPr lang="en-US" sz="4000" b="1" dirty="0">
                 <a:solidFill>
-                  <a:srgbClr val="156082"/>
+                  <a:srgbClr val="FFFFFF"/>
                 </a:solidFill>
-                <a:latin typeface="Aptos" pitchFamily="34" charset="0"/>
-                <a:ea typeface="Aptos" pitchFamily="34" charset="-122"/>
-                <a:cs typeface="Aptos" pitchFamily="34" charset="-120"/>
+                <a:latin typeface="Times New Roman" pitchFamily="34" charset="0"/>
+                <a:ea typeface="Times New Roman" pitchFamily="34" charset="-122"/>
+                <a:cs typeface="Times New Roman" pitchFamily="34" charset="-120"/>
               </a:rPr>
-              <a:t>OPEN TOOLKIT  ·  AIoT LAB · CUHK</a:t>
-            </a:r>
-            <a:endParaRPr lang="en-US" sz="1300" dirty="0"/>
+              <a:t>Nuna-Edu-Toolkit</a:t>
+            </a:r>
+            <a:endParaRPr lang="en-US" sz="4000" dirty="0"/>
           </a:p>
         </p:txBody>
       </p:sp>
       <p:sp>
         <p:nvSpPr>
-          <p:cNvPr id="3" name="Text 1"/>
+          <p:cNvPr id="4" name="Text 2"/>
           <p:cNvSpPr/>
           <p:nvPr/>
         </p:nvSpPr>
         <p:spPr>
           <a:xfrm>
-            <a:off x="658368" y="960120"/>
-            <a:ext cx="7315200" cy="868680"/>
+            <a:off x="6400800" y="0"/>
+            <a:ext cx="5330952" cy="1078992"/>
           </a:xfrm>
           <a:prstGeom prst="rect">
             <a:avLst/>
@@ -935,33 +955,33 @@
           <a:bodyPr wrap="square" lIns="0" tIns="0" rIns="0" bIns="0" rtlCol="0" anchor="ctr"/>
           <a:lstStyle/>
           <a:p>
-            <a:pPr indent="0" marL="0">
+            <a:pPr algn="r" indent="0" marL="0">
               <a:buNone/>
             </a:pPr>
             <a:r>
-              <a:rPr lang="en-US" sz="4600" b="1" dirty="0">
+              <a:rPr lang="en-US" sz="1300" b="1" spc="100" kern="0" dirty="0">
                 <a:solidFill>
-                  <a:srgbClr val="0E2841"/>
+                  <a:srgbClr val="FFFFFF"/>
                 </a:solidFill>
-                <a:latin typeface="Aptos Display" pitchFamily="34" charset="0"/>
-                <a:ea typeface="Aptos Display" pitchFamily="34" charset="-122"/>
-                <a:cs typeface="Aptos Display" pitchFamily="34" charset="-120"/>
+                <a:latin typeface="Times New Roman" pitchFamily="34" charset="0"/>
+                <a:ea typeface="Times New Roman" pitchFamily="34" charset="-122"/>
+                <a:cs typeface="Times New Roman" pitchFamily="34" charset="-120"/>
               </a:rPr>
-              <a:t>Nuna-Edu-Toolkit</a:t>
-            </a:r>
-            <a:endParaRPr lang="en-US" sz="4600" dirty="0"/>
+              <a:t>OPEN TOOLKIT  ·  AIoT LAB · CUHK</a:t>
+            </a:r>
+            <a:endParaRPr lang="en-US" sz="1300" dirty="0"/>
           </a:p>
         </p:txBody>
       </p:sp>
       <p:sp>
         <p:nvSpPr>
-          <p:cNvPr id="4" name="Text 2"/>
+          <p:cNvPr id="5" name="Text 3"/>
           <p:cNvSpPr/>
           <p:nvPr/>
         </p:nvSpPr>
         <p:spPr>
           <a:xfrm>
-            <a:off x="685800" y="1874520"/>
+            <a:off x="502920" y="1389888"/>
             <a:ext cx="7040880" cy="777240"/>
           </a:xfrm>
           <a:prstGeom prst="rect">
@@ -981,13 +1001,13 @@
               <a:buNone/>
             </a:pPr>
             <a:r>
-              <a:rPr lang="en-US" sz="2000" dirty="0">
+              <a:rPr lang="en-US" sz="2000" i="1" dirty="0">
                 <a:solidFill>
-                  <a:srgbClr val="1C2B39"/>
+                  <a:srgbClr val="1A1A1A"/>
                 </a:solidFill>
-                <a:latin typeface="Aptos" pitchFamily="34" charset="0"/>
-                <a:ea typeface="Aptos" pitchFamily="34" charset="-122"/>
-                <a:cs typeface="Aptos" pitchFamily="34" charset="-120"/>
+                <a:latin typeface="Times New Roman" pitchFamily="34" charset="0"/>
+                <a:ea typeface="Times New Roman" pitchFamily="34" charset="-122"/>
+                <a:cs typeface="Times New Roman" pitchFamily="34" charset="-120"/>
               </a:rPr>
               <a:t>Collect &amp; annotate first-person audio — and turn it into research datasets.</a:t>
             </a:r>
@@ -997,14 +1017,14 @@
       </p:sp>
       <p:sp>
         <p:nvSpPr>
-          <p:cNvPr id="5" name="Text 3"/>
+          <p:cNvPr id="6" name="Text 4"/>
           <p:cNvSpPr/>
           <p:nvPr/>
         </p:nvSpPr>
         <p:spPr>
           <a:xfrm>
-            <a:off x="713232" y="2788920"/>
-            <a:ext cx="7040880" cy="2468880"/>
+            <a:off x="548640" y="2697480"/>
+            <a:ext cx="7040880" cy="2926080"/>
           </a:xfrm>
           <a:prstGeom prst="rect">
             <a:avLst/>
@@ -1016,120 +1036,119 @@
           <a:bodyPr wrap="square" lIns="0" tIns="0" rIns="0" bIns="0" rtlCol="0" anchor="ctr"/>
           <a:lstStyle/>
           <a:p>
-            <a:pPr marL="203200" indent="-203200">
-              <a:buSzPct val="100000"/>
-              <a:buChar char="•"/>
+            <a:pPr indent="0" marL="0">
+              <a:buNone/>
             </a:pPr>
             <a:r>
-              <a:rPr lang="en-US" sz="1600" b="1" dirty="0">
+              <a:rPr lang="en-US" sz="1700" b="1" dirty="0">
                 <a:solidFill>
-                  <a:srgbClr val="156082"/>
+                  <a:srgbClr val="740E6C"/>
                 </a:solidFill>
-                <a:latin typeface="Aptos" pitchFamily="34" charset="0"/>
-                <a:ea typeface="Aptos" pitchFamily="34" charset="-122"/>
-                <a:cs typeface="Aptos" pitchFamily="34" charset="-120"/>
+                <a:latin typeface="Times New Roman" pitchFamily="34" charset="0"/>
+                <a:ea typeface="Times New Roman" pitchFamily="34" charset="-122"/>
+                <a:cs typeface="Times New Roman" pitchFamily="34" charset="-120"/>
               </a:rPr>
               <a:t>Capture</a:t>
             </a:r>
             <a:pPr indent="0" marL="0">
               <a:spcAft>
-                <a:spcPts val="1200"/>
+                <a:spcPts val="2200"/>
               </a:spcAft>
               <a:buNone/>
             </a:pPr>
             <a:r>
-              <a:rPr lang="en-US" sz="1600" dirty="0">
+              <a:rPr lang="en-US" sz="1700" dirty="0">
                 <a:solidFill>
-                  <a:srgbClr val="1C2B39"/>
+                  <a:srgbClr val="1A1A1A"/>
                 </a:solidFill>
-                <a:latin typeface="Aptos" pitchFamily="34" charset="0"/>
-                <a:ea typeface="Aptos" pitchFamily="34" charset="-122"/>
-                <a:cs typeface="Aptos" pitchFamily="34" charset="-120"/>
+                <a:latin typeface="Times New Roman" pitchFamily="34" charset="0"/>
+                <a:ea typeface="Times New Roman" pitchFamily="34" charset="-122"/>
+                <a:cs typeface="Times New Roman" pitchFamily="34" charset="-120"/>
               </a:rPr>
               <a:t>  wearable audio streamed to your own server, sliced into 1-minute segments</a:t>
             </a:r>
-            <a:endParaRPr lang="en-US" sz="1600" dirty="0"/>
+            <a:endParaRPr lang="en-US" sz="1700" dirty="0"/>
           </a:p>
           <a:p>
             <a:pPr indent="0" marL="0">
               <a:buNone/>
             </a:pPr>
             <a:r>
-              <a:rPr lang="en-US" sz="1600" b="1" dirty="0">
+              <a:rPr lang="en-US" sz="1700" b="1" dirty="0">
                 <a:solidFill>
-                  <a:srgbClr val="156082"/>
+                  <a:srgbClr val="740E6C"/>
                 </a:solidFill>
-                <a:latin typeface="Aptos" pitchFamily="34" charset="0"/>
-                <a:ea typeface="Aptos" pitchFamily="34" charset="-122"/>
-                <a:cs typeface="Aptos" pitchFamily="34" charset="-120"/>
+                <a:latin typeface="Times New Roman" pitchFamily="34" charset="0"/>
+                <a:ea typeface="Times New Roman" pitchFamily="34" charset="-122"/>
+                <a:cs typeface="Times New Roman" pitchFamily="34" charset="-120"/>
               </a:rPr>
               <a:t>Recall</a:t>
             </a:r>
             <a:pPr indent="0" marL="0">
               <a:spcAft>
-                <a:spcPts val="1200"/>
+                <a:spcPts val="2200"/>
               </a:spcAft>
               <a:buNone/>
             </a:pPr>
             <a:r>
-              <a:rPr lang="en-US" sz="1600" dirty="0">
+              <a:rPr lang="en-US" sz="1700" dirty="0">
                 <a:solidFill>
-                  <a:srgbClr val="1C2B39"/>
+                  <a:srgbClr val="1A1A1A"/>
                 </a:solidFill>
-                <a:latin typeface="Aptos" pitchFamily="34" charset="0"/>
-                <a:ea typeface="Aptos" pitchFamily="34" charset="-122"/>
-                <a:cs typeface="Aptos" pitchFamily="34" charset="-120"/>
+                <a:latin typeface="Times New Roman" pitchFamily="34" charset="0"/>
+                <a:ea typeface="Times New Roman" pitchFamily="34" charset="-122"/>
+                <a:cs typeface="Times New Roman" pitchFamily="34" charset="-120"/>
               </a:rPr>
               <a:t>  pluggable ASR previews (bring your own model) speed up annotation</a:t>
             </a:r>
-            <a:endParaRPr lang="en-US" sz="1600" dirty="0"/>
+            <a:endParaRPr lang="en-US" sz="1700" dirty="0"/>
           </a:p>
           <a:p>
             <a:pPr indent="0" marL="0">
               <a:buNone/>
             </a:pPr>
             <a:r>
-              <a:rPr lang="en-US" sz="1600" b="1" dirty="0">
+              <a:rPr lang="en-US" sz="1700" b="1" dirty="0">
                 <a:solidFill>
-                  <a:srgbClr val="156082"/>
+                  <a:srgbClr val="740E6C"/>
                 </a:solidFill>
-                <a:latin typeface="Aptos" pitchFamily="34" charset="0"/>
-                <a:ea typeface="Aptos" pitchFamily="34" charset="-122"/>
-                <a:cs typeface="Aptos" pitchFamily="34" charset="-120"/>
+                <a:latin typeface="Times New Roman" pitchFamily="34" charset="0"/>
+                <a:ea typeface="Times New Roman" pitchFamily="34" charset="-122"/>
+                <a:cs typeface="Times New Roman" pitchFamily="34" charset="-120"/>
               </a:rPr>
               <a:t>Annotate</a:t>
             </a:r>
             <a:pPr indent="0" marL="0">
               <a:spcAft>
-                <a:spcPts val="1200"/>
+                <a:spcPts val="2200"/>
               </a:spcAft>
               <a:buNone/>
             </a:pPr>
             <a:r>
-              <a:rPr lang="en-US" sz="1600" dirty="0">
+              <a:rPr lang="en-US" sz="1700" dirty="0">
                 <a:solidFill>
-                  <a:srgbClr val="1C2B39"/>
+                  <a:srgbClr val="1A1A1A"/>
                 </a:solidFill>
-                <a:latin typeface="Aptos" pitchFamily="34" charset="0"/>
-                <a:ea typeface="Aptos" pitchFamily="34" charset="-122"/>
-                <a:cs typeface="Aptos" pitchFamily="34" charset="-120"/>
+                <a:latin typeface="Times New Roman" pitchFamily="34" charset="0"/>
+                <a:ea typeface="Times New Roman" pitchFamily="34" charset="-122"/>
+                <a:cs typeface="Times New Roman" pitchFamily="34" charset="-120"/>
               </a:rPr>
               <a:t>  event-driven block + point labels — a swappable, multi-granularity schema</a:t>
             </a:r>
-            <a:endParaRPr lang="en-US" sz="1600" dirty="0"/>
+            <a:endParaRPr lang="en-US" sz="1700" dirty="0"/>
           </a:p>
           <a:p>
             <a:pPr indent="0" marL="0">
               <a:buNone/>
             </a:pPr>
             <a:r>
-              <a:rPr lang="en-US" sz="1600" b="1" dirty="0">
+              <a:rPr lang="en-US" sz="1700" b="1" dirty="0">
                 <a:solidFill>
-                  <a:srgbClr val="156082"/>
+                  <a:srgbClr val="740E6C"/>
                 </a:solidFill>
-                <a:latin typeface="Aptos" pitchFamily="34" charset="0"/>
-                <a:ea typeface="Aptos" pitchFamily="34" charset="-122"/>
-                <a:cs typeface="Aptos" pitchFamily="34" charset="-120"/>
+                <a:latin typeface="Times New Roman" pitchFamily="34" charset="0"/>
+                <a:ea typeface="Times New Roman" pitchFamily="34" charset="-122"/>
+                <a:cs typeface="Times New Roman" pitchFamily="34" charset="-120"/>
               </a:rPr>
               <a:t>Open</a:t>
             </a:r>
@@ -1137,135 +1156,23 @@
               <a:buNone/>
             </a:pPr>
             <a:r>
-              <a:rPr lang="en-US" sz="1600" dirty="0">
+              <a:rPr lang="en-US" sz="1700" dirty="0">
                 <a:solidFill>
-                  <a:srgbClr val="1C2B39"/>
+                  <a:srgbClr val="1A1A1A"/>
                 </a:solidFill>
-                <a:latin typeface="Aptos" pitchFamily="34" charset="0"/>
-                <a:ea typeface="Aptos" pitchFamily="34" charset="-122"/>
-                <a:cs typeface="Aptos" pitchFamily="34" charset="-120"/>
+                <a:latin typeface="Times New Roman" pitchFamily="34" charset="0"/>
+                <a:ea typeface="Times New Roman" pitchFamily="34" charset="-122"/>
+                <a:cs typeface="Times New Roman" pitchFamily="34" charset="-120"/>
               </a:rPr>
               <a:t>  self-hostable, privacy-first, free for non-commercial use</a:t>
             </a:r>
-            <a:endParaRPr lang="en-US" sz="1600" dirty="0"/>
-          </a:p>
-        </p:txBody>
-      </p:sp>
-      <p:sp>
-        <p:nvSpPr>
-          <p:cNvPr id="6" name="Text 4"/>
-          <p:cNvSpPr/>
-          <p:nvPr/>
-        </p:nvSpPr>
-        <p:spPr>
-          <a:xfrm>
-            <a:off x="685800" y="6309360"/>
-            <a:ext cx="10789920" cy="365760"/>
-          </a:xfrm>
-          <a:prstGeom prst="rect">
-            <a:avLst/>
-          </a:prstGeom>
-          <a:noFill/>
-          <a:ln/>
-        </p:spPr>
-        <p:txBody>
-          <a:bodyPr wrap="square" lIns="0" tIns="0" rIns="0" bIns="0" rtlCol="0" anchor="ctr"/>
-          <a:lstStyle/>
-          <a:p>
-            <a:pPr indent="0" marL="0">
-              <a:buNone/>
-            </a:pPr>
-            <a:r>
-              <a:rPr lang="en-US" sz="1100" dirty="0">
-                <a:solidFill>
-                  <a:srgbClr val="5B6B7A"/>
-                </a:solidFill>
-                <a:latin typeface="Aptos" pitchFamily="34" charset="0"/>
-                <a:ea typeface="Aptos" pitchFamily="34" charset="-122"/>
-                <a:cs typeface="Aptos" pitchFamily="34" charset="-120"/>
-              </a:rPr>
-              <a:t>Anlan Peng · Ruihan Xie · Yihang Su · Zhenyu Yan · Zhiyuan Xie · Guoliang Xing    —    AIoT Lab · The Chinese University of Hong Kong</a:t>
-            </a:r>
-            <a:endParaRPr lang="en-US" sz="1100" dirty="0"/>
-          </a:p>
-        </p:txBody>
-      </p:sp>
-      <p:sp>
-        <p:nvSpPr>
-          <p:cNvPr id="7" name="Shape 5"/>
-          <p:cNvSpPr/>
-          <p:nvPr/>
-        </p:nvSpPr>
-        <p:spPr>
-          <a:xfrm>
-            <a:off x="8229600" y="1188720"/>
-            <a:ext cx="3346704" cy="4526280"/>
-          </a:xfrm>
-          <a:prstGeom prst="roundRect">
-            <a:avLst>
-              <a:gd name="adj" fmla="val 3825"/>
-            </a:avLst>
-          </a:prstGeom>
-          <a:solidFill>
-            <a:srgbClr val="F4F7FB"/>
-          </a:solidFill>
-          <a:ln w="12700">
-            <a:solidFill>
-              <a:srgbClr val="DCE5EE"/>
-            </a:solidFill>
-            <a:prstDash val="solid"/>
-          </a:ln>
-          <a:effectLst>
-            <a:outerShdw sx="100000" sy="100000" kx="0" ky="0" algn="bl" rotWithShape="0" blurRad="114300" dist="38100" dir="8100000">
-              <a:srgbClr val="0E2841">
-                <a:alpha val="12000"/>
-              </a:srgbClr>
-            </a:outerShdw>
-          </a:effectLst>
-        </p:spPr>
-      </p:sp>
-      <p:sp>
-        <p:nvSpPr>
-          <p:cNvPr id="8" name="Text 6"/>
-          <p:cNvSpPr/>
-          <p:nvPr/>
-        </p:nvSpPr>
-        <p:spPr>
-          <a:xfrm>
-            <a:off x="8229600" y="1463040"/>
-            <a:ext cx="3346704" cy="320040"/>
-          </a:xfrm>
-          <a:prstGeom prst="rect">
-            <a:avLst/>
-          </a:prstGeom>
-          <a:noFill/>
-          <a:ln/>
-        </p:spPr>
-        <p:txBody>
-          <a:bodyPr wrap="square" lIns="0" tIns="0" rIns="0" bIns="0" rtlCol="0" anchor="ctr"/>
-          <a:lstStyle/>
-          <a:p>
-            <a:pPr algn="ctr" indent="0" marL="0">
-              <a:buNone/>
-            </a:pPr>
-            <a:r>
-              <a:rPr lang="en-US" sz="1300" b="1" spc="100" kern="0" dirty="0">
-                <a:solidFill>
-                  <a:srgbClr val="0E2841"/>
-                </a:solidFill>
-                <a:latin typeface="Aptos" pitchFamily="34" charset="0"/>
-                <a:ea typeface="Aptos" pitchFamily="34" charset="-122"/>
-                <a:cs typeface="Aptos" pitchFamily="34" charset="-120"/>
-              </a:rPr>
-              <a:t>SCAN TO DOWNLOAD &amp; TRY</a:t>
-            </a:r>
-            <a:endParaRPr lang="en-US" sz="1300" dirty="0"/>
+            <a:endParaRPr lang="en-US" sz="1700" dirty="0"/>
           </a:p>
         </p:txBody>
       </p:sp>
       <p:pic>
         <p:nvPicPr>
-          <p:cNvPr id="9" name="Image 0" descr="/Users/pal/Projects/nuna-edu-toolkit-release/site/assets/qr/site.png">    </p:cNvPr>
+          <p:cNvPr id="7" name="Image 0" descr="/Users/pal/Projects/nuna-edu-toolkit-release/site/assets/img/aiot-lab-logo.png">    </p:cNvPr>
           <p:cNvPicPr>
             <a:picLocks noChangeAspect="1"/>
           </p:cNvPicPr>
@@ -1279,8 +1186,8 @@
         </p:blipFill>
         <p:spPr>
           <a:xfrm>
-            <a:off x="8759952" y="1938528"/>
-            <a:ext cx="2286000" cy="2286000"/>
+            <a:off x="502920" y="5650992"/>
+            <a:ext cx="749808" cy="749808"/>
           </a:xfrm>
           <a:prstGeom prst="rect">
             <a:avLst/>
@@ -1289,14 +1196,14 @@
       </p:pic>
       <p:sp>
         <p:nvSpPr>
-          <p:cNvPr id="10" name="Text 7"/>
+          <p:cNvPr id="8" name="Text 5"/>
           <p:cNvSpPr/>
           <p:nvPr/>
         </p:nvSpPr>
         <p:spPr>
           <a:xfrm>
-            <a:off x="8229600" y="4352544"/>
-            <a:ext cx="3346704" cy="274320"/>
+            <a:off x="1389888" y="5705856"/>
+            <a:ext cx="10332720" cy="310896"/>
           </a:xfrm>
           <a:prstGeom prst="rect">
             <a:avLst/>
@@ -1308,34 +1215,198 @@
           <a:bodyPr wrap="square" lIns="0" tIns="0" rIns="0" bIns="0" rtlCol="0" anchor="ctr"/>
           <a:lstStyle/>
           <a:p>
+            <a:pPr indent="0" marL="0">
+              <a:buNone/>
+            </a:pPr>
+            <a:r>
+              <a:rPr lang="en-US" sz="1150" i="1" dirty="0">
+                <a:solidFill>
+                  <a:srgbClr val="6B5B68"/>
+                </a:solidFill>
+                <a:latin typeface="Times New Roman" pitchFamily="34" charset="0"/>
+                <a:ea typeface="Times New Roman" pitchFamily="34" charset="-122"/>
+                <a:cs typeface="Times New Roman" pitchFamily="34" charset="-120"/>
+              </a:rPr>
+              <a:t>Anlan Peng · Ruihan Xie · Yihang Su · Zhenyu Yan · Zhiyuan Xie · Guoliang Xing  —  AIoT Lab · The Chinese University of Hong Kong</a:t>
+            </a:r>
+            <a:endParaRPr lang="en-US" sz="1150" dirty="0"/>
+          </a:p>
+        </p:txBody>
+      </p:sp>
+      <p:sp>
+        <p:nvSpPr>
+          <p:cNvPr id="9" name="Text 6"/>
+          <p:cNvSpPr/>
+          <p:nvPr/>
+        </p:nvSpPr>
+        <p:spPr>
+          <a:xfrm>
+            <a:off x="1389888" y="6035040"/>
+            <a:ext cx="10332720" cy="310896"/>
+          </a:xfrm>
+          <a:prstGeom prst="rect">
+            <a:avLst/>
+          </a:prstGeom>
+          <a:noFill/>
+          <a:ln/>
+        </p:spPr>
+        <p:txBody>
+          <a:bodyPr wrap="square" lIns="0" tIns="0" rIns="0" bIns="0" rtlCol="0" anchor="ctr"/>
+          <a:lstStyle/>
+          <a:p>
+            <a:pPr indent="0" marL="0">
+              <a:buNone/>
+            </a:pPr>
+            <a:r>
+              <a:rPr lang="en-US" sz="1150" b="1" dirty="0">
+                <a:solidFill>
+                  <a:srgbClr val="740E6C"/>
+                </a:solidFill>
+                <a:latin typeface="Times New Roman" pitchFamily="34" charset="0"/>
+                <a:ea typeface="Times New Roman" pitchFamily="34" charset="-122"/>
+                <a:cs typeface="Times New Roman" pitchFamily="34" charset="-120"/>
+              </a:rPr>
+              <a:t>Contact   </a:t>
+            </a:r>
+            <a:pPr indent="0" marL="0">
+              <a:buNone/>
+            </a:pPr>
+            <a:r>
+              <a:rPr lang="en-US" sz="1150" dirty="0">
+                <a:solidFill>
+                  <a:srgbClr val="1A1A1A"/>
+                </a:solidFill>
+                <a:latin typeface="Times New Roman" pitchFamily="34" charset="0"/>
+                <a:ea typeface="Times New Roman" pitchFamily="34" charset="-122"/>
+                <a:cs typeface="Times New Roman" pitchFamily="34" charset="-120"/>
+              </a:rPr>
+              <a:t>Anlan Peng · pa025@ie.cuhk.edu.hk</a:t>
+            </a:r>
+            <a:pPr indent="0" marL="0">
+              <a:buNone/>
+            </a:pPr>
+            <a:r>
+              <a:rPr lang="en-US" sz="1150" dirty="0">
+                <a:solidFill>
+                  <a:srgbClr val="740E6C"/>
+                </a:solidFill>
+                <a:latin typeface="Times New Roman" pitchFamily="34" charset="0"/>
+                <a:ea typeface="Times New Roman" pitchFamily="34" charset="-122"/>
+                <a:cs typeface="Times New Roman" pitchFamily="34" charset="-120"/>
+              </a:rPr>
+              <a:t>        aiot.ie.cuhk.edu.hk</a:t>
+            </a:r>
+            <a:endParaRPr lang="en-US" sz="1150" dirty="0"/>
+          </a:p>
+        </p:txBody>
+      </p:sp>
+      <p:sp>
+        <p:nvSpPr>
+          <p:cNvPr id="10" name="Shape 7"/>
+          <p:cNvSpPr/>
+          <p:nvPr/>
+        </p:nvSpPr>
+        <p:spPr>
+          <a:xfrm>
+            <a:off x="8275320" y="1481328"/>
+            <a:ext cx="3383280" cy="4206240"/>
+          </a:xfrm>
+          <a:prstGeom prst="roundRect">
+            <a:avLst>
+              <a:gd name="adj" fmla="val 3243"/>
+            </a:avLst>
+          </a:prstGeom>
+          <a:solidFill>
+            <a:srgbClr val="F7EFF6"/>
+          </a:solidFill>
+          <a:ln w="12700">
+            <a:solidFill>
+              <a:srgbClr val="D9BBD5"/>
+            </a:solidFill>
+            <a:prstDash val="solid"/>
+          </a:ln>
+          <a:effectLst>
+            <a:outerShdw sx="100000" sy="100000" kx="0" ky="0" algn="bl" rotWithShape="0" blurRad="114300" dist="38100" dir="8100000">
+              <a:srgbClr val="740E6C">
+                <a:alpha val="14000"/>
+              </a:srgbClr>
+            </a:outerShdw>
+          </a:effectLst>
+        </p:spPr>
+      </p:sp>
+      <p:sp>
+        <p:nvSpPr>
+          <p:cNvPr id="11" name="Text 8"/>
+          <p:cNvSpPr/>
+          <p:nvPr/>
+        </p:nvSpPr>
+        <p:spPr>
+          <a:xfrm>
+            <a:off x="8275320" y="1755648"/>
+            <a:ext cx="3383280" cy="320040"/>
+          </a:xfrm>
+          <a:prstGeom prst="rect">
+            <a:avLst/>
+          </a:prstGeom>
+          <a:noFill/>
+          <a:ln/>
+        </p:spPr>
+        <p:txBody>
+          <a:bodyPr wrap="square" lIns="0" tIns="0" rIns="0" bIns="0" rtlCol="0" anchor="ctr"/>
+          <a:lstStyle/>
+          <a:p>
             <a:pPr algn="ctr" indent="0" marL="0">
               <a:buNone/>
             </a:pPr>
             <a:r>
-              <a:rPr lang="en-US" sz="1200" dirty="0">
+              <a:rPr lang="en-US" sz="1400" b="1" spc="100" kern="0" dirty="0">
                 <a:solidFill>
-                  <a:srgbClr val="5B6B7A"/>
+                  <a:srgbClr val="740E6C"/>
                 </a:solidFill>
-                <a:latin typeface="Aptos" pitchFamily="34" charset="0"/>
-                <a:ea typeface="Aptos" pitchFamily="34" charset="-122"/>
-                <a:cs typeface="Aptos" pitchFamily="34" charset="-120"/>
+                <a:latin typeface="Times New Roman" pitchFamily="34" charset="0"/>
+                <a:ea typeface="Times New Roman" pitchFamily="34" charset="-122"/>
+                <a:cs typeface="Times New Roman" pitchFamily="34" charset="-120"/>
               </a:rPr>
-              <a:t>Demo  ·  App  ·  Source — one link</a:t>
-            </a:r>
-            <a:endParaRPr lang="en-US" sz="1200" dirty="0"/>
+              <a:t>SCAN TO DOWNLOAD &amp; TRY</a:t>
+            </a:r>
+            <a:endParaRPr lang="en-US" sz="1400" dirty="0"/>
           </a:p>
         </p:txBody>
       </p:sp>
-      <p:sp>
-        <p:nvSpPr>
-          <p:cNvPr id="11" name="Text 8"/>
+      <p:pic>
+        <p:nvPicPr>
+          <p:cNvPr id="12" name="Image 1" descr="/Users/pal/Projects/nuna-edu-toolkit-release/site/assets/qr/site.png">    </p:cNvPr>
+          <p:cNvPicPr>
+            <a:picLocks noChangeAspect="1"/>
+          </p:cNvPicPr>
+          <p:nvPr/>
+        </p:nvPicPr>
+        <p:blipFill>
+          <a:blip r:embed="rId2"/>
+          <a:stretch>
+            <a:fillRect/>
+          </a:stretch>
+        </p:blipFill>
+        <p:spPr>
+          <a:xfrm>
+            <a:off x="8869680" y="2231136"/>
+            <a:ext cx="2194560" cy="2194560"/>
+          </a:xfrm>
+          <a:prstGeom prst="rect">
+            <a:avLst/>
+          </a:prstGeom>
+        </p:spPr>
+      </p:pic>
+      <p:sp>
+        <p:nvSpPr>
+          <p:cNvPr id="13" name="Text 9"/>
           <p:cNvSpPr/>
           <p:nvPr/>
         </p:nvSpPr>
         <p:spPr>
           <a:xfrm>
-            <a:off x="8229600" y="4626864"/>
-            <a:ext cx="3346704" cy="274320"/>
+            <a:off x="8275320" y="4572000"/>
+            <a:ext cx="3383280" cy="274320"/>
           </a:xfrm>
           <a:prstGeom prst="rect">
             <a:avLst/>
@@ -1351,19 +1422,118 @@
               <a:buNone/>
             </a:pPr>
             <a:r>
-              <a:rPr lang="en-US" sz="1050" dirty="0">
+              <a:rPr lang="en-US" sz="1250" dirty="0">
                 <a:solidFill>
-                  <a:srgbClr val="156082"/>
+                  <a:srgbClr val="6B5B68"/>
                 </a:solidFill>
-                <a:latin typeface="Aptos" pitchFamily="34" charset="0"/>
-                <a:ea typeface="Aptos" pitchFamily="34" charset="-122"/>
-                <a:cs typeface="Aptos" pitchFamily="34" charset="-120"/>
+                <a:latin typeface="Times New Roman" pitchFamily="34" charset="0"/>
+                <a:ea typeface="Times New Roman" pitchFamily="34" charset="-122"/>
+                <a:cs typeface="Times New Roman" pitchFamily="34" charset="-120"/>
+              </a:rPr>
+              <a:t>Demo  ·  App  ·  Source — one link</a:t>
+            </a:r>
+            <a:endParaRPr lang="en-US" sz="1250" dirty="0"/>
+          </a:p>
+        </p:txBody>
+      </p:sp>
+      <p:sp>
+        <p:nvSpPr>
+          <p:cNvPr id="14" name="Text 10"/>
+          <p:cNvSpPr/>
+          <p:nvPr/>
+        </p:nvSpPr>
+        <p:spPr>
+          <a:xfrm>
+            <a:off x="8275320" y="4864608"/>
+            <a:ext cx="3383280" cy="274320"/>
+          </a:xfrm>
+          <a:prstGeom prst="rect">
+            <a:avLst/>
+          </a:prstGeom>
+          <a:noFill/>
+          <a:ln/>
+        </p:spPr>
+        <p:txBody>
+          <a:bodyPr wrap="square" lIns="0" tIns="0" rIns="0" bIns="0" rtlCol="0" anchor="ctr"/>
+          <a:lstStyle/>
+          <a:p>
+            <a:pPr algn="ctr" indent="0" marL="0">
+              <a:buNone/>
+            </a:pPr>
+            <a:r>
+              <a:rPr lang="en-US" sz="1100" b="1" dirty="0">
+                <a:solidFill>
+                  <a:srgbClr val="740E6C"/>
+                </a:solidFill>
+                <a:latin typeface="Times New Roman" pitchFamily="34" charset="0"/>
+                <a:ea typeface="Times New Roman" pitchFamily="34" charset="-122"/>
+                <a:cs typeface="Times New Roman" pitchFamily="34" charset="-120"/>
               </a:rPr>
               <a:t>kevin-pal.github.io/nuna-edu-toolkit-release</a:t>
             </a:r>
-            <a:endParaRPr lang="en-US" sz="1050" dirty="0"/>
+            <a:endParaRPr lang="en-US" sz="1100" dirty="0"/>
           </a:p>
         </p:txBody>
+      </p:sp>
+      <p:sp>
+        <p:nvSpPr>
+          <p:cNvPr id="15" name="Shape 11"/>
+          <p:cNvSpPr/>
+          <p:nvPr/>
+        </p:nvSpPr>
+        <p:spPr>
+          <a:xfrm>
+            <a:off x="0" y="6565392"/>
+            <a:ext cx="4063898" cy="292608"/>
+          </a:xfrm>
+          <a:prstGeom prst="rect">
+            <a:avLst/>
+          </a:prstGeom>
+          <a:solidFill>
+            <a:srgbClr val="570B51"/>
+          </a:solidFill>
+          <a:ln/>
+        </p:spPr>
+      </p:sp>
+      <p:sp>
+        <p:nvSpPr>
+          <p:cNvPr id="16" name="Shape 12"/>
+          <p:cNvSpPr/>
+          <p:nvPr/>
+        </p:nvSpPr>
+        <p:spPr>
+          <a:xfrm>
+            <a:off x="4063898" y="6565392"/>
+            <a:ext cx="4063898" cy="292608"/>
+          </a:xfrm>
+          <a:prstGeom prst="rect">
+            <a:avLst/>
+          </a:prstGeom>
+          <a:solidFill>
+            <a:srgbClr val="740E6C"/>
+          </a:solidFill>
+          <a:ln/>
+        </p:spPr>
+      </p:sp>
+      <p:sp>
+        <p:nvSpPr>
+          <p:cNvPr id="17" name="Shape 13"/>
+          <p:cNvSpPr/>
+          <p:nvPr/>
+        </p:nvSpPr>
+        <p:spPr>
+          <a:xfrm>
+            <a:off x="8127797" y="6565392"/>
+            <a:ext cx="4063898" cy="292608"/>
+          </a:xfrm>
+          <a:prstGeom prst="rect">
+            <a:avLst/>
+          </a:prstGeom>
+          <a:solidFill>
+            <a:srgbClr val="570B51"/>
+          </a:solidFill>
+          <a:ln/>
+        </p:spPr>
       </p:sp>
     </p:spTree>
   </p:cSld>

</xml_diff>